<commit_message>
Folio final: roles, Team screen, sandbox, settings, submission folder, docs; remove legacy MOTIF files
Co-Authored-By: Claude Sonnet 5.5 <noreply@anthropic.com>
Claude-Session: https://claude.ai/code/session_01Fr7KHTkupJUiaF5WVwZjVq
</commit_message>
<xml_diff>
--- a/docs/archive/MOTIF_DesignProposal_v3.pptx
+++ b/docs/archive/MOTIF_DesignProposal_v3.pptx
@@ -595,7 +595,7 @@
           <a:p>
             <a:r>
               <a:rPr lang="en-US" dirty="0"/>
-              <a:t>SCRIPT: Hi, we're Team MOTIF. Between the four of us we've got design, tech, art and research backgrounds, and we've deliberately split our roles to stretch each of us rather than just play to what we're already good at. Dylan's been leading our research synthesis and documentation. Pranav's driving audience research and content. Mohammad owns the technical build, especially scoping our AR feature. And Paul's handling media and interview capture. We're a small team, but between us we've already done six user interviews, which we'll get into shortly.</a:t>
+              <a:t>SCRIPT: Hi, we're Team MOTIF. Between the four of us we've got design, tech, art and research backgrounds, and we've deliberately split our roles to stretch each of us rather than just play to what we're already good at. Dylan's been leading our research synthesis and documentation. Pranav's driving audience research and content. Shaz owns the technical build, especially scoping our AR feature. And Paul's handling media and interview capture. We're a small team, but between us we've already done six user interviews, which we'll get into shortly.</a:t>
             </a:r>
             <a:endParaRPr lang="en-US" dirty="0"/>
           </a:p>
@@ -683,7 +683,7 @@
           <a:p>
             <a:r>
               <a:rPr lang="en-US" dirty="0"/>
-              <a:t>SCRIPT: So what's the actual problem we're solving? Globally, people spend almost 21 hours a week listening to music, and 44% are actively discovering new artists weekly - that's IFPI's 2023 global survey data. But recent research from this year's WWW conference found something interesting: recommendation algorithms actually narrow what we're exposed to rather than opening it up - they flatten the differences between what different people hear. And this isn't just one of us saying it - three of us interviewed completely different people, independently, and got the same answer back. Dylan's participant Aloysious said, quoting directly, 'I just want it to be more human focused. Algorithm has ruined the taste - no fun, no randomness to it.' Pranav's participant said, 'Just tell me what's happening near me that people I trust are into. Not what a machine thinks I'll click.' And Mohammad's participant Minahil, a resident doctor, said everything feels very algorithm-driven and she wants to discover things more naturally. Three separate interviews, same gap. That's what we're designing into.</a:t>
+              <a:t>SCRIPT: So what's the actual problem we're solving? Globally, people spend almost 21 hours a week listening to music, and 44% are actively discovering new artists weekly - that's IFPI's 2023 global survey data. But recent research from this year's WWW conference found something interesting: recommendation algorithms actually narrow what we're exposed to rather than opening it up - they flatten the differences between what different people hear. And this isn't just one of us saying it - three of us interviewed completely different people, independently, and got the same answer back. Dylan's participant R1-F said, quoting directly, 'I just want it to be more human focused. Algorithm has ruined the taste - no fun, no randomness to it.' Pranav's participant said, 'Just tell me what's happening near me that people I trust are into. Not what a machine thinks I'll click.' And Shaz's participant R1-C, a resident doctor, said everything feels very algorithm-driven and she wants to discover things more naturally. Three separate interviews, same gap. That's what we're designing into.</a:t>
             </a:r>
             <a:endParaRPr lang="en-US" dirty="0"/>
           </a:p>
@@ -1339,6 +1339,10 @@
           </a:solidFill>
           <a:ln/>
         </p:spPr>
+        <p:txBody>
+          <a:bodyPr/>
+          <a:p/>
+        </p:txBody>
       </p:sp>
       <p:sp>
         <p:nvSpPr>
@@ -1366,6 +1370,10 @@
             <a:prstDash val="solid"/>
           </a:ln>
         </p:spPr>
+        <p:txBody>
+          <a:bodyPr/>
+          <a:p/>
+        </p:txBody>
       </p:sp>
       <p:sp>
         <p:nvSpPr>
@@ -1523,6 +1531,10 @@
             <a:prstDash val="solid"/>
           </a:ln>
         </p:spPr>
+        <p:txBody>
+          <a:bodyPr/>
+          <a:p/>
+        </p:txBody>
       </p:sp>
       <p:sp>
         <p:nvSpPr>
@@ -1550,6 +1562,10 @@
             <a:prstDash val="solid"/>
           </a:ln>
         </p:spPr>
+        <p:txBody>
+          <a:bodyPr/>
+          <a:p/>
+        </p:txBody>
       </p:sp>
       <p:sp>
         <p:nvSpPr>
@@ -1616,6 +1632,10 @@
             <a:prstDash val="solid"/>
           </a:ln>
         </p:spPr>
+        <p:txBody>
+          <a:bodyPr/>
+          <a:p/>
+        </p:txBody>
       </p:sp>
       <p:sp>
         <p:nvSpPr>
@@ -1682,6 +1702,10 @@
             <a:prstDash val="solid"/>
           </a:ln>
         </p:spPr>
+        <p:txBody>
+          <a:bodyPr/>
+          <a:p/>
+        </p:txBody>
       </p:sp>
       <p:sp>
         <p:nvSpPr>
@@ -1716,7 +1740,7 @@
                 <a:ea typeface="Trebuchet MS" pitchFamily="34" charset="-122"/>
                 <a:cs typeface="Trebuchet MS" pitchFamily="34" charset="-120"/>
               </a:rPr>
-              <a:t>Mohammad</a:t>
+              <a:t>Shaz</a:t>
             </a:r>
             <a:endParaRPr lang="en-US" sz="1300" dirty="0"/>
           </a:p>
@@ -1748,6 +1772,10 @@
             <a:prstDash val="solid"/>
           </a:ln>
         </p:spPr>
+        <p:txBody>
+          <a:bodyPr/>
+          <a:p/>
+        </p:txBody>
       </p:sp>
       <p:sp>
         <p:nvSpPr>
@@ -2058,6 +2086,10 @@
             <a:prstDash val="solid"/>
           </a:ln>
         </p:spPr>
+        <p:txBody>
+          <a:bodyPr/>
+          <a:p/>
+        </p:txBody>
       </p:sp>
       <p:sp>
         <p:nvSpPr>
@@ -2083,6 +2115,10 @@
             <a:prstDash val="solid"/>
           </a:ln>
         </p:spPr>
+        <p:txBody>
+          <a:bodyPr/>
+          <a:p/>
+        </p:txBody>
       </p:sp>
       <p:sp>
         <p:nvSpPr>
@@ -2266,6 +2302,10 @@
             <a:prstDash val="solid"/>
           </a:ln>
         </p:spPr>
+        <p:txBody>
+          <a:bodyPr/>
+          <a:p/>
+        </p:txBody>
       </p:sp>
       <p:sp>
         <p:nvSpPr>
@@ -2291,6 +2331,10 @@
             <a:prstDash val="solid"/>
           </a:ln>
         </p:spPr>
+        <p:txBody>
+          <a:bodyPr/>
+          <a:p/>
+        </p:txBody>
       </p:sp>
       <p:sp>
         <p:nvSpPr>
@@ -2474,6 +2518,10 @@
             <a:prstDash val="solid"/>
           </a:ln>
         </p:spPr>
+        <p:txBody>
+          <a:bodyPr/>
+          <a:p/>
+        </p:txBody>
       </p:sp>
       <p:sp>
         <p:nvSpPr>
@@ -2499,6 +2547,10 @@
             <a:prstDash val="solid"/>
           </a:ln>
         </p:spPr>
+        <p:txBody>
+          <a:bodyPr/>
+          <a:p/>
+        </p:txBody>
       </p:sp>
       <p:sp>
         <p:nvSpPr>
@@ -2572,7 +2624,7 @@
                 <a:ea typeface="Trebuchet MS" pitchFamily="34" charset="-122"/>
                 <a:cs typeface="Trebuchet MS" pitchFamily="34" charset="-120"/>
               </a:rPr>
-              <a:t>Mohammad</a:t>
+              <a:t>Shaz</a:t>
             </a:r>
             <a:endParaRPr lang="en-US" sz="1700" dirty="0"/>
           </a:p>
@@ -2682,6 +2734,10 @@
             <a:prstDash val="solid"/>
           </a:ln>
         </p:spPr>
+        <p:txBody>
+          <a:bodyPr/>
+          <a:p/>
+        </p:txBody>
       </p:sp>
       <p:sp>
         <p:nvSpPr>
@@ -2707,6 +2763,10 @@
             <a:prstDash val="solid"/>
           </a:ln>
         </p:spPr>
+        <p:txBody>
+          <a:bodyPr/>
+          <a:p/>
+        </p:txBody>
       </p:sp>
       <p:sp>
         <p:nvSpPr>
@@ -3035,6 +3095,10 @@
             <a:prstDash val="solid"/>
           </a:ln>
         </p:spPr>
+        <p:txBody>
+          <a:bodyPr/>
+          <a:p/>
+        </p:txBody>
       </p:sp>
       <p:sp>
         <p:nvSpPr>
@@ -3101,6 +3165,10 @@
             <a:prstDash val="solid"/>
           </a:ln>
         </p:spPr>
+        <p:txBody>
+          <a:bodyPr/>
+          <a:p/>
+        </p:txBody>
       </p:sp>
       <p:sp>
         <p:nvSpPr>
@@ -3245,6 +3313,10 @@
             <a:prstDash val="solid"/>
           </a:ln>
         </p:spPr>
+        <p:txBody>
+          <a:bodyPr/>
+          <a:p/>
+        </p:txBody>
       </p:sp>
       <p:sp>
         <p:nvSpPr>
@@ -3389,6 +3461,10 @@
             <a:prstDash val="solid"/>
           </a:ln>
         </p:spPr>
+        <p:txBody>
+          <a:bodyPr/>
+          <a:p/>
+        </p:txBody>
       </p:sp>
       <p:sp>
         <p:nvSpPr>
@@ -3572,6 +3648,10 @@
             <a:prstDash val="solid"/>
           </a:ln>
         </p:spPr>
+        <p:txBody>
+          <a:bodyPr/>
+          <a:p/>
+        </p:txBody>
       </p:sp>
       <p:sp>
         <p:nvSpPr>
@@ -3718,6 +3798,10 @@
           </a:solidFill>
           <a:ln/>
         </p:spPr>
+        <p:txBody>
+          <a:bodyPr/>
+          <a:p/>
+        </p:txBody>
       </p:sp>
       <p:sp>
         <p:nvSpPr>
@@ -3821,6 +3905,10 @@
             <a:prstDash val="solid"/>
           </a:ln>
         </p:spPr>
+        <p:txBody>
+          <a:bodyPr/>
+          <a:p/>
+        </p:txBody>
       </p:sp>
       <p:sp>
         <p:nvSpPr>
@@ -3894,7 +3982,7 @@
                 <a:ea typeface="Verdana" pitchFamily="34" charset="-122"/>
                 <a:cs typeface="Verdana" pitchFamily="34" charset="-120"/>
               </a:rPr>
-              <a:t>— Aloysious, 28, India · interviewed by Dylan</a:t>
+              <a:t>— R1-F, 28, India · interviewed by Dylan</a:t>
             </a:r>
             <a:endParaRPr lang="en-US" sz="750" dirty="0"/>
           </a:p>
@@ -3924,6 +4012,10 @@
             <a:prstDash val="solid"/>
           </a:ln>
         </p:spPr>
+        <p:txBody>
+          <a:bodyPr/>
+          <a:p/>
+        </p:txBody>
       </p:sp>
       <p:sp>
         <p:nvSpPr>
@@ -4027,6 +4119,10 @@
             <a:prstDash val="solid"/>
           </a:ln>
         </p:spPr>
+        <p:txBody>
+          <a:bodyPr/>
+          <a:p/>
+        </p:txBody>
       </p:sp>
       <p:sp>
         <p:nvSpPr>
@@ -4100,7 +4196,7 @@
                 <a:ea typeface="Verdana" pitchFamily="34" charset="-122"/>
                 <a:cs typeface="Verdana" pitchFamily="34" charset="-120"/>
               </a:rPr>
-              <a:t>— Minahil · interviewed by Mohammad</a:t>
+              <a:t>— R1-C · interviewed by Shaz</a:t>
             </a:r>
             <a:endParaRPr lang="en-US" sz="750" dirty="0"/>
           </a:p>
@@ -4277,6 +4373,10 @@
             <a:prstDash val="solid"/>
           </a:ln>
         </p:spPr>
+        <p:txBody>
+          <a:bodyPr/>
+          <a:p/>
+        </p:txBody>
       </p:sp>
       <p:sp>
         <p:nvSpPr>
@@ -4343,6 +4443,10 @@
             <a:prstDash val="solid"/>
           </a:ln>
         </p:spPr>
+        <p:txBody>
+          <a:bodyPr/>
+          <a:p/>
+        </p:txBody>
       </p:sp>
       <p:sp>
         <p:nvSpPr>
@@ -4487,6 +4591,10 @@
             <a:prstDash val="solid"/>
           </a:ln>
         </p:spPr>
+        <p:txBody>
+          <a:bodyPr/>
+          <a:p/>
+        </p:txBody>
       </p:sp>
       <p:sp>
         <p:nvSpPr>
@@ -4570,6 +4678,10 @@
             <a:prstDash val="solid"/>
           </a:ln>
         </p:spPr>
+        <p:txBody>
+          <a:bodyPr/>
+          <a:p/>
+        </p:txBody>
       </p:sp>
       <p:sp>
         <p:nvSpPr>
@@ -4653,6 +4765,10 @@
             <a:prstDash val="solid"/>
           </a:ln>
         </p:spPr>
+        <p:txBody>
+          <a:bodyPr/>
+          <a:p/>
+        </p:txBody>
       </p:sp>
       <p:sp>
         <p:nvSpPr>
@@ -4736,6 +4852,10 @@
             <a:prstDash val="solid"/>
           </a:ln>
         </p:spPr>
+        <p:txBody>
+          <a:bodyPr/>
+          <a:p/>
+        </p:txBody>
       </p:sp>
       <p:sp>
         <p:nvSpPr>
@@ -4819,6 +4939,10 @@
             <a:prstDash val="solid"/>
           </a:ln>
         </p:spPr>
+        <p:txBody>
+          <a:bodyPr/>
+          <a:p/>
+        </p:txBody>
       </p:sp>
       <p:sp>
         <p:nvSpPr>
@@ -4980,6 +5104,10 @@
             <a:prstDash val="solid"/>
           </a:ln>
         </p:spPr>
+        <p:txBody>
+          <a:bodyPr/>
+          <a:p/>
+        </p:txBody>
       </p:sp>
       <p:sp>
         <p:nvSpPr>
@@ -5085,6 +5213,10 @@
             <a:prstDash val="solid"/>
           </a:ln>
         </p:spPr>
+        <p:txBody>
+          <a:bodyPr/>
+          <a:p/>
+        </p:txBody>
       </p:sp>
       <p:sp>
         <p:nvSpPr>
@@ -5190,6 +5322,10 @@
             <a:prstDash val="solid"/>
           </a:ln>
         </p:spPr>
+        <p:txBody>
+          <a:bodyPr/>
+          <a:p/>
+        </p:txBody>
       </p:sp>
       <p:sp>
         <p:nvSpPr>
@@ -5295,6 +5431,10 @@
             <a:prstDash val="solid"/>
           </a:ln>
         </p:spPr>
+        <p:txBody>
+          <a:bodyPr/>
+          <a:p/>
+        </p:txBody>
       </p:sp>
       <p:sp>
         <p:nvSpPr>
@@ -5545,6 +5685,10 @@
             <a:prstDash val="solid"/>
           </a:ln>
         </p:spPr>
+        <p:txBody>
+          <a:bodyPr/>
+          <a:p/>
+        </p:txBody>
       </p:sp>
       <p:sp>
         <p:nvSpPr>
@@ -5611,6 +5755,10 @@
             <a:prstDash val="solid"/>
           </a:ln>
         </p:spPr>
+        <p:txBody>
+          <a:bodyPr/>
+          <a:p/>
+        </p:txBody>
       </p:sp>
       <p:sp>
         <p:nvSpPr>
@@ -5645,7 +5793,7 @@
                 <a:ea typeface="Trebuchet MS" pitchFamily="34" charset="-122"/>
                 <a:cs typeface="Trebuchet MS" pitchFamily="34" charset="-120"/>
               </a:rPr>
-              <a:t>Marushka</a:t>
+              <a:t>R1-A</a:t>
             </a:r>
             <a:endParaRPr lang="en-US" sz="1100" dirty="0"/>
           </a:p>
@@ -5716,6 +5864,10 @@
             <a:prstDash val="solid"/>
           </a:ln>
         </p:spPr>
+        <p:txBody>
+          <a:bodyPr/>
+          <a:p/>
+        </p:txBody>
       </p:sp>
       <p:sp>
         <p:nvSpPr>
@@ -5750,7 +5902,7 @@
                 <a:ea typeface="Trebuchet MS" pitchFamily="34" charset="-122"/>
                 <a:cs typeface="Trebuchet MS" pitchFamily="34" charset="-120"/>
               </a:rPr>
-              <a:t>Pritesh</a:t>
+              <a:t>R1-B</a:t>
             </a:r>
             <a:endParaRPr lang="en-US" sz="1100" dirty="0"/>
           </a:p>
@@ -5821,6 +5973,10 @@
             <a:prstDash val="solid"/>
           </a:ln>
         </p:spPr>
+        <p:txBody>
+          <a:bodyPr/>
+          <a:p/>
+        </p:txBody>
       </p:sp>
       <p:sp>
         <p:nvSpPr>
@@ -5855,7 +6011,7 @@
                 <a:ea typeface="Trebuchet MS" pitchFamily="34" charset="-122"/>
                 <a:cs typeface="Trebuchet MS" pitchFamily="34" charset="-120"/>
               </a:rPr>
-              <a:t>Minahil</a:t>
+              <a:t>R1-C</a:t>
             </a:r>
             <a:endParaRPr lang="en-US" sz="1100" dirty="0"/>
           </a:p>
@@ -5926,6 +6082,10 @@
             <a:prstDash val="solid"/>
           </a:ln>
         </p:spPr>
+        <p:txBody>
+          <a:bodyPr/>
+          <a:p/>
+        </p:txBody>
       </p:sp>
       <p:sp>
         <p:nvSpPr>
@@ -5960,7 +6120,7 @@
                 <a:ea typeface="Trebuchet MS" pitchFamily="34" charset="-122"/>
                 <a:cs typeface="Trebuchet MS" pitchFamily="34" charset="-120"/>
               </a:rPr>
-              <a:t>Rayyan</a:t>
+              <a:t>R1-D</a:t>
             </a:r>
             <a:endParaRPr lang="en-US" sz="1100" dirty="0"/>
           </a:p>
@@ -6031,6 +6191,10 @@
             <a:prstDash val="solid"/>
           </a:ln>
         </p:spPr>
+        <p:txBody>
+          <a:bodyPr/>
+          <a:p/>
+        </p:txBody>
       </p:sp>
       <p:sp>
         <p:nvSpPr>
@@ -6065,7 +6229,7 @@
                 <a:ea typeface="Trebuchet MS" pitchFamily="34" charset="-122"/>
                 <a:cs typeface="Trebuchet MS" pitchFamily="34" charset="-120"/>
               </a:rPr>
-              <a:t>Sully</a:t>
+              <a:t>R1-E</a:t>
             </a:r>
             <a:endParaRPr lang="en-US" sz="1100" dirty="0"/>
           </a:p>
@@ -6136,6 +6300,10 @@
             <a:prstDash val="solid"/>
           </a:ln>
         </p:spPr>
+        <p:txBody>
+          <a:bodyPr/>
+          <a:p/>
+        </p:txBody>
       </p:sp>
       <p:sp>
         <p:nvSpPr>
@@ -6170,7 +6338,7 @@
                 <a:ea typeface="Trebuchet MS" pitchFamily="34" charset="-122"/>
                 <a:cs typeface="Trebuchet MS" pitchFamily="34" charset="-120"/>
               </a:rPr>
-              <a:t>Aloysious</a:t>
+              <a:t>R1-F</a:t>
             </a:r>
             <a:endParaRPr lang="en-US" sz="1100" dirty="0"/>
           </a:p>
@@ -6241,6 +6409,10 @@
             <a:prstDash val="solid"/>
           </a:ln>
         </p:spPr>
+        <p:txBody>
+          <a:bodyPr/>
+          <a:p/>
+        </p:txBody>
       </p:sp>
       <p:sp>
         <p:nvSpPr>
@@ -6346,6 +6518,10 @@
             <a:prstDash val="solid"/>
           </a:ln>
         </p:spPr>
+        <p:txBody>
+          <a:bodyPr/>
+          <a:p/>
+        </p:txBody>
       </p:sp>
       <p:sp>
         <p:nvSpPr>
@@ -6451,6 +6627,10 @@
             <a:prstDash val="solid"/>
           </a:ln>
         </p:spPr>
+        <p:txBody>
+          <a:bodyPr/>
+          <a:p/>
+        </p:txBody>
       </p:sp>
       <p:sp>
         <p:nvSpPr>
@@ -6556,6 +6736,10 @@
             <a:prstDash val="solid"/>
           </a:ln>
         </p:spPr>
+        <p:txBody>
+          <a:bodyPr/>
+          <a:p/>
+        </p:txBody>
       </p:sp>
       <p:sp>
         <p:nvSpPr>
@@ -6806,6 +6990,10 @@
             <a:prstDash val="solid"/>
           </a:ln>
         </p:spPr>
+        <p:txBody>
+          <a:bodyPr/>
+          <a:p/>
+        </p:txBody>
       </p:sp>
       <p:sp>
         <p:nvSpPr>
@@ -7116,6 +7304,10 @@
             <a:prstDash val="solid"/>
           </a:ln>
         </p:spPr>
+        <p:txBody>
+          <a:bodyPr/>
+          <a:p/>
+        </p:txBody>
       </p:sp>
       <p:sp>
         <p:nvSpPr>
@@ -7257,6 +7449,10 @@
             <a:tailEnd type="triangle"/>
           </a:ln>
         </p:spPr>
+        <p:txBody>
+          <a:bodyPr/>
+          <a:p/>
+        </p:txBody>
       </p:sp>
       <p:sp>
         <p:nvSpPr>
@@ -7284,6 +7480,10 @@
             <a:prstDash val="solid"/>
           </a:ln>
         </p:spPr>
+        <p:txBody>
+          <a:bodyPr/>
+          <a:p/>
+        </p:txBody>
       </p:sp>
       <p:sp>
         <p:nvSpPr>
@@ -7425,6 +7625,10 @@
             <a:tailEnd type="triangle"/>
           </a:ln>
         </p:spPr>
+        <p:txBody>
+          <a:bodyPr/>
+          <a:p/>
+        </p:txBody>
       </p:sp>
       <p:sp>
         <p:nvSpPr>
@@ -7452,6 +7656,10 @@
             <a:prstDash val="solid"/>
           </a:ln>
         </p:spPr>
+        <p:txBody>
+          <a:bodyPr/>
+          <a:p/>
+        </p:txBody>
       </p:sp>
       <p:sp>
         <p:nvSpPr>
@@ -7593,6 +7801,10 @@
             <a:tailEnd type="triangle"/>
           </a:ln>
         </p:spPr>
+        <p:txBody>
+          <a:bodyPr/>
+          <a:p/>
+        </p:txBody>
       </p:sp>
       <p:sp>
         <p:nvSpPr>
@@ -7620,6 +7832,10 @@
             <a:prstDash val="solid"/>
           </a:ln>
         </p:spPr>
+        <p:txBody>
+          <a:bodyPr/>
+          <a:p/>
+        </p:txBody>
       </p:sp>
       <p:sp>
         <p:nvSpPr>
@@ -7761,6 +7977,10 @@
             <a:tailEnd type="triangle"/>
           </a:ln>
         </p:spPr>
+        <p:txBody>
+          <a:bodyPr/>
+          <a:p/>
+        </p:txBody>
       </p:sp>
       <p:sp>
         <p:nvSpPr>
@@ -7788,6 +8008,10 @@
             <a:prstDash val="solid"/>
           </a:ln>
         </p:spPr>
+        <p:txBody>
+          <a:bodyPr/>
+          <a:p/>
+        </p:txBody>
       </p:sp>
       <p:sp>
         <p:nvSpPr>

</xml_diff>